<commit_message>
updated week 1 - 6 slides with disclaimer
</commit_message>
<xml_diff>
--- a/Week1/Week1_Slides.pptx
+++ b/Week1/Week1_Slides.pptx
@@ -117,6 +117,11 @@
       </a:defRPr>
     </a:lvl9pPr>
   </p:defaultTextStyle>
+  <p:extLst>
+    <p:ext uri="{EFAFB233-063F-42B5-8137-9DF3F51BA10A}">
+      <p15:sldGuideLst xmlns:p15="http://schemas.microsoft.com/office/powerpoint/2012/main"/>
+    </p:ext>
+  </p:extLst>
 </p:presentation>
 </file>
 
@@ -306,7 +311,7 @@
           <a:p>
             <a:fld id="{0325F2DB-684C-436C-B81C-9D88E6EDD596}" type="datetimeFigureOut">
               <a:rPr lang="en-IN" smtClean="0"/>
-              <a:t>18-05-2025</a:t>
+              <a:t>02-07-2025</a:t>
             </a:fld>
             <a:endParaRPr lang="en-IN"/>
           </a:p>
@@ -581,7 +586,7 @@
           <a:p>
             <a:fld id="{0325F2DB-684C-436C-B81C-9D88E6EDD596}" type="datetimeFigureOut">
               <a:rPr lang="en-IN" smtClean="0"/>
-              <a:t>18-05-2025</a:t>
+              <a:t>02-07-2025</a:t>
             </a:fld>
             <a:endParaRPr lang="en-IN"/>
           </a:p>
@@ -775,7 +780,7 @@
           <a:p>
             <a:fld id="{0325F2DB-684C-436C-B81C-9D88E6EDD596}" type="datetimeFigureOut">
               <a:rPr lang="en-IN" smtClean="0"/>
-              <a:t>18-05-2025</a:t>
+              <a:t>02-07-2025</a:t>
             </a:fld>
             <a:endParaRPr lang="en-IN"/>
           </a:p>
@@ -1048,7 +1053,7 @@
           <a:p>
             <a:fld id="{0325F2DB-684C-436C-B81C-9D88E6EDD596}" type="datetimeFigureOut">
               <a:rPr lang="en-IN" smtClean="0"/>
-              <a:t>18-05-2025</a:t>
+              <a:t>02-07-2025</a:t>
             </a:fld>
             <a:endParaRPr lang="en-IN"/>
           </a:p>
@@ -1389,7 +1394,7 @@
           <a:p>
             <a:fld id="{0325F2DB-684C-436C-B81C-9D88E6EDD596}" type="datetimeFigureOut">
               <a:rPr lang="en-IN" smtClean="0"/>
-              <a:t>18-05-2025</a:t>
+              <a:t>02-07-2025</a:t>
             </a:fld>
             <a:endParaRPr lang="en-IN"/>
           </a:p>
@@ -2012,7 +2017,7 @@
           <a:p>
             <a:fld id="{0325F2DB-684C-436C-B81C-9D88E6EDD596}" type="datetimeFigureOut">
               <a:rPr lang="en-IN" smtClean="0"/>
-              <a:t>18-05-2025</a:t>
+              <a:t>02-07-2025</a:t>
             </a:fld>
             <a:endParaRPr lang="en-IN"/>
           </a:p>
@@ -2872,7 +2877,7 @@
           <a:p>
             <a:fld id="{0325F2DB-684C-436C-B81C-9D88E6EDD596}" type="datetimeFigureOut">
               <a:rPr lang="en-IN" smtClean="0"/>
-              <a:t>18-05-2025</a:t>
+              <a:t>02-07-2025</a:t>
             </a:fld>
             <a:endParaRPr lang="en-IN"/>
           </a:p>
@@ -3042,7 +3047,7 @@
           <a:p>
             <a:fld id="{0325F2DB-684C-436C-B81C-9D88E6EDD596}" type="datetimeFigureOut">
               <a:rPr lang="en-IN" smtClean="0"/>
-              <a:t>18-05-2025</a:t>
+              <a:t>02-07-2025</a:t>
             </a:fld>
             <a:endParaRPr lang="en-IN"/>
           </a:p>
@@ -3222,7 +3227,7 @@
           <a:p>
             <a:fld id="{0325F2DB-684C-436C-B81C-9D88E6EDD596}" type="datetimeFigureOut">
               <a:rPr lang="en-IN" smtClean="0"/>
-              <a:t>18-05-2025</a:t>
+              <a:t>02-07-2025</a:t>
             </a:fld>
             <a:endParaRPr lang="en-IN"/>
           </a:p>
@@ -3392,7 +3397,7 @@
           <a:p>
             <a:fld id="{0325F2DB-684C-436C-B81C-9D88E6EDD596}" type="datetimeFigureOut">
               <a:rPr lang="en-IN" smtClean="0"/>
-              <a:t>18-05-2025</a:t>
+              <a:t>02-07-2025</a:t>
             </a:fld>
             <a:endParaRPr lang="en-IN"/>
           </a:p>
@@ -3639,7 +3644,7 @@
           <a:p>
             <a:fld id="{0325F2DB-684C-436C-B81C-9D88E6EDD596}" type="datetimeFigureOut">
               <a:rPr lang="en-IN" smtClean="0"/>
-              <a:t>18-05-2025</a:t>
+              <a:t>02-07-2025</a:t>
             </a:fld>
             <a:endParaRPr lang="en-IN"/>
           </a:p>
@@ -3931,7 +3936,7 @@
           <a:p>
             <a:fld id="{0325F2DB-684C-436C-B81C-9D88E6EDD596}" type="datetimeFigureOut">
               <a:rPr lang="en-IN" smtClean="0"/>
-              <a:t>18-05-2025</a:t>
+              <a:t>02-07-2025</a:t>
             </a:fld>
             <a:endParaRPr lang="en-IN"/>
           </a:p>
@@ -4375,7 +4380,7 @@
           <a:p>
             <a:fld id="{0325F2DB-684C-436C-B81C-9D88E6EDD596}" type="datetimeFigureOut">
               <a:rPr lang="en-IN" smtClean="0"/>
-              <a:t>18-05-2025</a:t>
+              <a:t>02-07-2025</a:t>
             </a:fld>
             <a:endParaRPr lang="en-IN"/>
           </a:p>
@@ -4493,7 +4498,7 @@
           <a:p>
             <a:fld id="{0325F2DB-684C-436C-B81C-9D88E6EDD596}" type="datetimeFigureOut">
               <a:rPr lang="en-IN" smtClean="0"/>
-              <a:t>18-05-2025</a:t>
+              <a:t>02-07-2025</a:t>
             </a:fld>
             <a:endParaRPr lang="en-IN"/>
           </a:p>
@@ -4588,7 +4593,7 @@
           <a:p>
             <a:fld id="{0325F2DB-684C-436C-B81C-9D88E6EDD596}" type="datetimeFigureOut">
               <a:rPr lang="en-IN" smtClean="0"/>
-              <a:t>18-05-2025</a:t>
+              <a:t>02-07-2025</a:t>
             </a:fld>
             <a:endParaRPr lang="en-IN"/>
           </a:p>
@@ -4867,7 +4872,7 @@
           <a:p>
             <a:fld id="{0325F2DB-684C-436C-B81C-9D88E6EDD596}" type="datetimeFigureOut">
               <a:rPr lang="en-IN" smtClean="0"/>
-              <a:t>18-05-2025</a:t>
+              <a:t>02-07-2025</a:t>
             </a:fld>
             <a:endParaRPr lang="en-IN"/>
           </a:p>
@@ -5142,7 +5147,7 @@
           <a:p>
             <a:fld id="{0325F2DB-684C-436C-B81C-9D88E6EDD596}" type="datetimeFigureOut">
               <a:rPr lang="en-IN" smtClean="0"/>
-              <a:t>18-05-2025</a:t>
+              <a:t>02-07-2025</a:t>
             </a:fld>
             <a:endParaRPr lang="en-IN"/>
           </a:p>
@@ -5571,7 +5576,7 @@
           <a:p>
             <a:fld id="{0325F2DB-684C-436C-B81C-9D88E6EDD596}" type="datetimeFigureOut">
               <a:rPr lang="en-IN" smtClean="0"/>
-              <a:t>18-05-2025</a:t>
+              <a:t>02-07-2025</a:t>
             </a:fld>
             <a:endParaRPr lang="en-IN"/>
           </a:p>
@@ -6859,6 +6864,41 @@
           </a:p>
         </p:txBody>
       </p:sp>
+      <p:sp>
+        <p:nvSpPr>
+          <p:cNvPr id="4" name="TextBox 3">
+            <a:extLst>
+              <a:ext uri="{FF2B5EF4-FFF2-40B4-BE49-F238E27FC236}">
+                <a16:creationId xmlns:a16="http://schemas.microsoft.com/office/drawing/2014/main" id="{FA913225-BB86-9D04-9B59-A5EB56004DB2}"/>
+              </a:ext>
+            </a:extLst>
+          </p:cNvPr>
+          <p:cNvSpPr txBox="1"/>
+          <p:nvPr/>
+        </p:nvSpPr>
+        <p:spPr>
+          <a:xfrm>
+            <a:off x="646111" y="6405282"/>
+            <a:ext cx="5925020" cy="369332"/>
+          </a:xfrm>
+          <a:prstGeom prst="rect">
+            <a:avLst/>
+          </a:prstGeom>
+          <a:noFill/>
+        </p:spPr>
+        <p:txBody>
+          <a:bodyPr wrap="none" rtlCol="0">
+            <a:spAutoFit/>
+          </a:bodyPr>
+          <a:lstStyle/>
+          <a:p>
+            <a:r>
+              <a:rPr lang="en-IN" dirty="0"/>
+              <a:t>Disclaimer – For course use only; do not redistribute.</a:t>
+            </a:r>
+          </a:p>
+        </p:txBody>
+      </p:sp>
     </p:spTree>
     <p:extLst>
       <p:ext uri="{BB962C8B-B14F-4D97-AF65-F5344CB8AC3E}">

</xml_diff>